<commit_message>
Troca cards sem foto de espelhos e coberturas por faixa "Também fazemos"
O catálogo não tem fotos desses dois serviços; a faixa tipográfica evita a
aparência de foto faltando e libera altura para ampliar as fotos dos
outros quatro cards.

Co-Authored-By: Claude Opus 5.5 <noreply@anthropic.com>
Claude-Session: https://claude.ai/code/session_016SBqUKXSKtikeVmD6Aj6Cp
</commit_message>
<xml_diff>
--- a/jp-aluminios/entregas/JP-Aluminios-Apresentacao-editavel.pptx
+++ b/jp-aluminios/entregas/JP-Aluminios-Apresentacao-editavel.pptx
@@ -4520,7 +4520,7 @@
         <p:spPr>
           <a:xfrm>
             <a:off x="576000" y="2808000"/>
-            <a:ext cx="3096000" cy="2232000"/>
+            <a:ext cx="3096000" cy="2520000"/>
           </a:xfrm>
           <a:prstGeom prst="rect">
             <a:avLst/>
@@ -4542,7 +4542,7 @@
       </p:sp>
       <p:pic>
         <p:nvPicPr>
-          <p:cNvPr id="8" name="Picture 7" descr="013_86x35_8e09.jpg"/>
+          <p:cNvPr id="8" name="Picture 7" descr="013_86x43_8e09.jpg"/>
           <p:cNvPicPr>
             <a:picLocks noChangeAspect="1"/>
           </p:cNvPicPr>
@@ -4557,7 +4557,7 @@
         <p:spPr>
           <a:xfrm>
             <a:off x="576000" y="2808000"/>
-            <a:ext cx="3096000" cy="1260000"/>
+            <a:ext cx="3096000" cy="1548000"/>
           </a:xfrm>
           <a:prstGeom prst="rect">
             <a:avLst/>
@@ -4572,7 +4572,7 @@
         </p:nvSpPr>
         <p:spPr>
           <a:xfrm>
-            <a:off x="756000" y="4212000"/>
+            <a:off x="756000" y="4500000"/>
             <a:ext cx="2736000" cy="252000"/>
           </a:xfrm>
           <a:prstGeom prst="rect">
@@ -4611,7 +4611,7 @@
         </p:nvSpPr>
         <p:spPr>
           <a:xfrm>
-            <a:off x="756000" y="4482000"/>
+            <a:off x="756000" y="4770000"/>
             <a:ext cx="2736000" cy="468000"/>
           </a:xfrm>
           <a:prstGeom prst="rect">
@@ -4651,7 +4651,7 @@
         <p:spPr>
           <a:xfrm>
             <a:off x="3888000" y="2808000"/>
-            <a:ext cx="3096000" cy="2232000"/>
+            <a:ext cx="3096000" cy="2520000"/>
           </a:xfrm>
           <a:prstGeom prst="rect">
             <a:avLst/>
@@ -4673,7 +4673,7 @@
       </p:sp>
       <p:pic>
         <p:nvPicPr>
-          <p:cNvPr id="12" name="Picture 11" descr="050_86x35_348b.jpg"/>
+          <p:cNvPr id="12" name="Picture 11" descr="050_86x43_348b.jpg"/>
           <p:cNvPicPr>
             <a:picLocks noChangeAspect="1"/>
           </p:cNvPicPr>
@@ -4688,7 +4688,7 @@
         <p:spPr>
           <a:xfrm>
             <a:off x="3888000" y="2808000"/>
-            <a:ext cx="3096000" cy="1260000"/>
+            <a:ext cx="3096000" cy="1548000"/>
           </a:xfrm>
           <a:prstGeom prst="rect">
             <a:avLst/>
@@ -4703,7 +4703,7 @@
         </p:nvSpPr>
         <p:spPr>
           <a:xfrm>
-            <a:off x="4068000" y="4212000"/>
+            <a:off x="4068000" y="4500000"/>
             <a:ext cx="2736000" cy="252000"/>
           </a:xfrm>
           <a:prstGeom prst="rect">
@@ -4742,7 +4742,7 @@
         </p:nvSpPr>
         <p:spPr>
           <a:xfrm>
-            <a:off x="4068000" y="4482000"/>
+            <a:off x="4068000" y="4770000"/>
             <a:ext cx="2736000" cy="468000"/>
           </a:xfrm>
           <a:prstGeom prst="rect">
@@ -4781,8 +4781,8 @@
         </p:nvSpPr>
         <p:spPr>
           <a:xfrm>
-            <a:off x="576000" y="5220000"/>
-            <a:ext cx="3096000" cy="2232000"/>
+            <a:off x="576000" y="5508000"/>
+            <a:ext cx="3096000" cy="2520000"/>
           </a:xfrm>
           <a:prstGeom prst="rect">
             <a:avLst/>
@@ -4804,7 +4804,7 @@
       </p:sp>
       <p:pic>
         <p:nvPicPr>
-          <p:cNvPr id="16" name="Picture 15" descr="040_86x35_33bd.jpg"/>
+          <p:cNvPr id="16" name="Picture 15" descr="040_86x43_33bd.jpg"/>
           <p:cNvPicPr>
             <a:picLocks noChangeAspect="1"/>
           </p:cNvPicPr>
@@ -4818,8 +4818,8 @@
         </p:blipFill>
         <p:spPr>
           <a:xfrm>
-            <a:off x="576000" y="5220000"/>
-            <a:ext cx="3096000" cy="1260000"/>
+            <a:off x="576000" y="5508000"/>
+            <a:ext cx="3096000" cy="1548000"/>
           </a:xfrm>
           <a:prstGeom prst="rect">
             <a:avLst/>
@@ -4834,7 +4834,7 @@
         </p:nvSpPr>
         <p:spPr>
           <a:xfrm>
-            <a:off x="756000" y="6624000"/>
+            <a:off x="756000" y="7200000"/>
             <a:ext cx="2736000" cy="252000"/>
           </a:xfrm>
           <a:prstGeom prst="rect">
@@ -4873,7 +4873,7 @@
         </p:nvSpPr>
         <p:spPr>
           <a:xfrm>
-            <a:off x="756000" y="6894000"/>
+            <a:off x="756000" y="7470000"/>
             <a:ext cx="2736000" cy="468000"/>
           </a:xfrm>
           <a:prstGeom prst="rect">
@@ -4912,8 +4912,8 @@
         </p:nvSpPr>
         <p:spPr>
           <a:xfrm>
-            <a:off x="3888000" y="5220000"/>
-            <a:ext cx="3096000" cy="2232000"/>
+            <a:off x="3888000" y="5508000"/>
+            <a:ext cx="3096000" cy="2520000"/>
           </a:xfrm>
           <a:prstGeom prst="rect">
             <a:avLst/>
@@ -4935,7 +4935,7 @@
       </p:sp>
       <p:pic>
         <p:nvPicPr>
-          <p:cNvPr id="20" name="Picture 19" descr="041_86x35_348b.jpg"/>
+          <p:cNvPr id="20" name="Picture 19" descr="041_86x43_348b.jpg"/>
           <p:cNvPicPr>
             <a:picLocks noChangeAspect="1"/>
           </p:cNvPicPr>
@@ -4949,8 +4949,8 @@
         </p:blipFill>
         <p:spPr>
           <a:xfrm>
-            <a:off x="3888000" y="5220000"/>
-            <a:ext cx="3096000" cy="1260000"/>
+            <a:off x="3888000" y="5508000"/>
+            <a:ext cx="3096000" cy="1548000"/>
           </a:xfrm>
           <a:prstGeom prst="rect">
             <a:avLst/>
@@ -4965,7 +4965,7 @@
         </p:nvSpPr>
         <p:spPr>
           <a:xfrm>
-            <a:off x="4068000" y="6624000"/>
+            <a:off x="4068000" y="7200000"/>
             <a:ext cx="2736000" cy="252000"/>
           </a:xfrm>
           <a:prstGeom prst="rect">
@@ -5004,7 +5004,7 @@
         </p:nvSpPr>
         <p:spPr>
           <a:xfrm>
-            <a:off x="4068000" y="6894000"/>
+            <a:off x="4068000" y="7470000"/>
             <a:ext cx="2736000" cy="468000"/>
           </a:xfrm>
           <a:prstGeom prst="rect">
@@ -5043,8 +5043,8 @@
         </p:nvSpPr>
         <p:spPr>
           <a:xfrm>
-            <a:off x="576000" y="7632000"/>
-            <a:ext cx="3096000" cy="2232000"/>
+            <a:off x="576000" y="8208000"/>
+            <a:ext cx="6408000" cy="1584000"/>
           </a:xfrm>
           <a:prstGeom prst="rect">
             <a:avLst/>
@@ -5072,14 +5072,14 @@
         </p:nvSpPr>
         <p:spPr>
           <a:xfrm>
-            <a:off x="576000" y="7632000"/>
-            <a:ext cx="3096000" cy="1260000"/>
+            <a:off x="576000" y="8208000"/>
+            <a:ext cx="6408000" cy="21600"/>
           </a:xfrm>
           <a:prstGeom prst="rect">
             <a:avLst/>
           </a:prstGeom>
           <a:solidFill>
-            <a:srgbClr val="22252A"/>
+            <a:srgbClr val="C9A26B"/>
           </a:solidFill>
           <a:ln>
             <a:noFill/>
@@ -5093,9 +5093,106 @@
           </a:p>
         </p:txBody>
       </p:sp>
+      <p:sp>
+        <p:nvSpPr>
+          <p:cNvPr id="25" name="TextBox 24"/>
+          <p:cNvSpPr txBox="1"/>
+          <p:nvPr/>
+        </p:nvSpPr>
+        <p:spPr>
+          <a:xfrm>
+            <a:off x="792000" y="8442000"/>
+            <a:ext cx="5976000" cy="216000"/>
+          </a:xfrm>
+          <a:prstGeom prst="rect">
+            <a:avLst/>
+          </a:prstGeom>
+          <a:noFill/>
+        </p:spPr>
+        <p:txBody>
+          <a:bodyPr wrap="square" lIns="0" rIns="0" tIns="0" bIns="0" anchor="t">
+            <a:noAutofit/>
+          </a:bodyPr>
+          <a:lstStyle/>
+          <a:p>
+            <a:pPr algn="l">
+              <a:lnSpc>
+                <a:spcPts val="1687"/>
+              </a:lnSpc>
+            </a:pPr>
+            <a:r>
+              <a:rPr sz="1250" b="1" spc="200">
+                <a:solidFill>
+                  <a:srgbClr val="C9A26B"/>
+                </a:solidFill>
+                <a:latin typeface="Barlow Condensed"/>
+              </a:rPr>
+              <a:t>TAMBÉM FAZEMOS</a:t>
+            </a:r>
+          </a:p>
+        </p:txBody>
+      </p:sp>
+      <p:sp>
+        <p:nvSpPr>
+          <p:cNvPr id="26" name="Rectangle 25"/>
+          <p:cNvSpPr/>
+          <p:nvPr/>
+        </p:nvSpPr>
+        <p:spPr>
+          <a:xfrm>
+            <a:off x="3780000" y="8820000"/>
+            <a:ext cx="10800" cy="756000"/>
+          </a:xfrm>
+          <a:prstGeom prst="rect">
+            <a:avLst/>
+          </a:prstGeom>
+          <a:solidFill>
+            <a:srgbClr val="33373D"/>
+          </a:solidFill>
+          <a:ln>
+            <a:noFill/>
+          </a:ln>
+        </p:spPr>
+        <p:txBody>
+          <a:bodyPr rtlCol="0" anchor="ctr"/>
+          <a:lstStyle/>
+          <a:p>
+            <a:pPr algn="ctr"/>
+          </a:p>
+        </p:txBody>
+      </p:sp>
+      <p:sp>
+        <p:nvSpPr>
+          <p:cNvPr id="27" name="Oval 26"/>
+          <p:cNvSpPr/>
+          <p:nvPr/>
+        </p:nvSpPr>
+        <p:spPr>
+          <a:xfrm>
+            <a:off x="792000" y="8820000"/>
+            <a:ext cx="504000" cy="504000"/>
+          </a:xfrm>
+          <a:prstGeom prst="ellipse">
+            <a:avLst/>
+          </a:prstGeom>
+          <a:noFill/>
+          <a:ln w="16200">
+            <a:solidFill>
+              <a:srgbClr val="C9A26B"/>
+            </a:solidFill>
+          </a:ln>
+        </p:spPr>
+        <p:txBody>
+          <a:bodyPr rtlCol="0" anchor="ctr"/>
+          <a:lstStyle/>
+          <a:p>
+            <a:pPr algn="ctr"/>
+          </a:p>
+        </p:txBody>
+      </p:sp>
       <p:pic>
         <p:nvPicPr>
-          <p:cNvPr id="25" name="Picture 24" descr="icon_espelho.png"/>
+          <p:cNvPr id="28" name="Picture 27" descr="icon_espelho.png"/>
           <p:cNvPicPr>
             <a:picLocks noChangeAspect="1"/>
           </p:cNvPicPr>
@@ -5109,8 +5206,8 @@
         </p:blipFill>
         <p:spPr>
           <a:xfrm>
-            <a:off x="1733400" y="7871400"/>
-            <a:ext cx="781200" cy="781200"/>
+            <a:off x="900000" y="8928000"/>
+            <a:ext cx="288000" cy="288000"/>
           </a:xfrm>
           <a:prstGeom prst="rect">
             <a:avLst/>
@@ -5119,14 +5216,14 @@
       </p:pic>
       <p:sp>
         <p:nvSpPr>
-          <p:cNvPr id="26" name="TextBox 25"/>
+          <p:cNvPr id="29" name="TextBox 28"/>
           <p:cNvSpPr txBox="1"/>
           <p:nvPr/>
         </p:nvSpPr>
         <p:spPr>
           <a:xfrm>
-            <a:off x="756000" y="9036000"/>
-            <a:ext cx="2736000" cy="252000"/>
+            <a:off x="1458000" y="8830800"/>
+            <a:ext cx="2178000" cy="252000"/>
           </a:xfrm>
           <a:prstGeom prst="rect">
             <a:avLst/>
@@ -5141,11 +5238,11 @@
           <a:p>
             <a:pPr algn="l">
               <a:lnSpc>
-                <a:spcPts val="1700"/>
-              </a:lnSpc>
-            </a:pPr>
-            <a:r>
-              <a:rPr sz="1700" b="1" spc="51">
+                <a:spcPts val="1550"/>
+              </a:lnSpc>
+            </a:pPr>
+            <a:r>
+              <a:rPr sz="1550" b="1" spc="46">
                 <a:solidFill>
                   <a:srgbClr val="F4F2EE"/>
                 </a:solidFill>
@@ -5158,14 +5255,14 @@
       </p:sp>
       <p:sp>
         <p:nvSpPr>
-          <p:cNvPr id="27" name="TextBox 26"/>
+          <p:cNvPr id="30" name="TextBox 29"/>
           <p:cNvSpPr txBox="1"/>
           <p:nvPr/>
         </p:nvSpPr>
         <p:spPr>
           <a:xfrm>
-            <a:off x="756000" y="9306000"/>
-            <a:ext cx="2736000" cy="468000"/>
+            <a:off x="1458000" y="9090000"/>
+            <a:ext cx="2178000" cy="468000"/>
           </a:xfrm>
           <a:prstGeom prst="rect">
             <a:avLst/>
@@ -5190,59 +5287,30 @@
                 </a:solidFill>
                 <a:latin typeface="Barlow"/>
               </a:rPr>
-              <a:t>Espelhos sob medida que ampliam e valorizam os ambientes.</a:t>
-            </a:r>
-          </a:p>
-        </p:txBody>
-      </p:sp>
-      <p:sp>
-        <p:nvSpPr>
-          <p:cNvPr id="28" name="Rectangle 27"/>
+              <a:t>Sob medida, para ampliar e valorizar os ambientes.</a:t>
+            </a:r>
+          </a:p>
+        </p:txBody>
+      </p:sp>
+      <p:sp>
+        <p:nvSpPr>
+          <p:cNvPr id="31" name="Oval 30"/>
           <p:cNvSpPr/>
           <p:nvPr/>
         </p:nvSpPr>
         <p:spPr>
           <a:xfrm>
-            <a:off x="3888000" y="7632000"/>
-            <a:ext cx="3096000" cy="2232000"/>
-          </a:xfrm>
-          <a:prstGeom prst="rect">
-            <a:avLst/>
-          </a:prstGeom>
-          <a:solidFill>
-            <a:srgbClr val="181A1D"/>
-          </a:solidFill>
-          <a:ln>
-            <a:noFill/>
-          </a:ln>
-        </p:spPr>
-        <p:txBody>
-          <a:bodyPr rtlCol="0" anchor="ctr"/>
-          <a:lstStyle/>
-          <a:p>
-            <a:pPr algn="ctr"/>
-          </a:p>
-        </p:txBody>
-      </p:sp>
-      <p:sp>
-        <p:nvSpPr>
-          <p:cNvPr id="29" name="Rectangle 28"/>
-          <p:cNvSpPr/>
-          <p:nvPr/>
-        </p:nvSpPr>
-        <p:spPr>
-          <a:xfrm>
-            <a:off x="3888000" y="7632000"/>
-            <a:ext cx="3096000" cy="1260000"/>
-          </a:xfrm>
-          <a:prstGeom prst="rect">
-            <a:avLst/>
-          </a:prstGeom>
-          <a:solidFill>
-            <a:srgbClr val="22252A"/>
-          </a:solidFill>
-          <a:ln>
-            <a:noFill/>
+            <a:off x="3924000" y="8820000"/>
+            <a:ext cx="504000" cy="504000"/>
+          </a:xfrm>
+          <a:prstGeom prst="ellipse">
+            <a:avLst/>
+          </a:prstGeom>
+          <a:noFill/>
+          <a:ln w="16200">
+            <a:solidFill>
+              <a:srgbClr val="C9A26B"/>
+            </a:solidFill>
           </a:ln>
         </p:spPr>
         <p:txBody>
@@ -5255,7 +5323,7 @@
       </p:sp>
       <p:pic>
         <p:nvPicPr>
-          <p:cNvPr id="30" name="Picture 29" descr="icon_pergolado.png"/>
+          <p:cNvPr id="32" name="Picture 31" descr="icon_pergolado.png"/>
           <p:cNvPicPr>
             <a:picLocks noChangeAspect="1"/>
           </p:cNvPicPr>
@@ -5269,8 +5337,8 @@
         </p:blipFill>
         <p:spPr>
           <a:xfrm>
-            <a:off x="5045400" y="7871400"/>
-            <a:ext cx="781200" cy="781200"/>
+            <a:off x="4032000" y="8928000"/>
+            <a:ext cx="288000" cy="288000"/>
           </a:xfrm>
           <a:prstGeom prst="rect">
             <a:avLst/>
@@ -5279,14 +5347,14 @@
       </p:pic>
       <p:sp>
         <p:nvSpPr>
-          <p:cNvPr id="31" name="TextBox 30"/>
+          <p:cNvPr id="33" name="TextBox 32"/>
           <p:cNvSpPr txBox="1"/>
           <p:nvPr/>
         </p:nvSpPr>
         <p:spPr>
           <a:xfrm>
-            <a:off x="4068000" y="9036000"/>
-            <a:ext cx="2736000" cy="252000"/>
+            <a:off x="4590000" y="8830800"/>
+            <a:ext cx="2178000" cy="252000"/>
           </a:xfrm>
           <a:prstGeom prst="rect">
             <a:avLst/>
@@ -5301,11 +5369,11 @@
           <a:p>
             <a:pPr algn="l">
               <a:lnSpc>
-                <a:spcPts val="1700"/>
-              </a:lnSpc>
-            </a:pPr>
-            <a:r>
-              <a:rPr sz="1700" b="1" spc="51">
+                <a:spcPts val="1550"/>
+              </a:lnSpc>
+            </a:pPr>
+            <a:r>
+              <a:rPr sz="1550" b="1" spc="46">
                 <a:solidFill>
                   <a:srgbClr val="F4F2EE"/>
                 </a:solidFill>
@@ -5318,14 +5386,14 @@
       </p:sp>
       <p:sp>
         <p:nvSpPr>
-          <p:cNvPr id="32" name="TextBox 31"/>
+          <p:cNvPr id="34" name="TextBox 33"/>
           <p:cNvSpPr txBox="1"/>
           <p:nvPr/>
         </p:nvSpPr>
         <p:spPr>
           <a:xfrm>
-            <a:off x="4068000" y="9306000"/>
-            <a:ext cx="2736000" cy="468000"/>
+            <a:off x="4590000" y="9090000"/>
+            <a:ext cx="2178000" cy="468000"/>
           </a:xfrm>
           <a:prstGeom prst="rect">
             <a:avLst/>
@@ -5357,7 +5425,7 @@
       </p:sp>
       <p:sp>
         <p:nvSpPr>
-          <p:cNvPr id="33" name="Rectangle 32"/>
+          <p:cNvPr id="35" name="Rectangle 34"/>
           <p:cNvSpPr/>
           <p:nvPr/>
         </p:nvSpPr>
@@ -5386,7 +5454,7 @@
       </p:sp>
       <p:pic>
         <p:nvPicPr>
-          <p:cNvPr id="34" name="Picture 33" descr="logo_white.png"/>
+          <p:cNvPr id="36" name="Picture 35" descr="logo_white.png"/>
           <p:cNvPicPr>
             <a:picLocks noChangeAspect="1"/>
           </p:cNvPicPr>
@@ -5410,7 +5478,7 @@
       </p:pic>
       <p:sp>
         <p:nvSpPr>
-          <p:cNvPr id="35" name="TextBox 34">
+          <p:cNvPr id="37" name="TextBox 36">
             <a:hlinkClick r:id="rId9"/>
           </p:cNvPr>
           <p:cNvSpPr txBox="1"/>

</xml_diff>

<commit_message>
Adiciona portfólio Checkmate + Liqsy e motor compartilhado de apresentações
Portfólio de 9 páginas para o representante comercial, com marcas Baldo,
linhas Checkmate e Liqsy e fichas técnicas de drinks (custo e lucro
conferidos). O motor em motor/ passa a gerar PDF, PDF leve, PPTX e JPGs
para os dois projetos; a JP Alumínios foi migrada sem mudança visual.

Co-Authored-By: Claude Opus 5.5 <noreply@anthropic.com>
Claude-Session: https://claude.ai/code/session_016SBqUKXSKtikeVmD6Aj6Cp
</commit_message>
<xml_diff>
--- a/jp-aluminios/entregas/JP-Aluminios-Apresentacao-editavel.pptx
+++ b/jp-aluminios/entregas/JP-Aluminios-Apresentacao-editavel.pptx
@@ -3133,7 +3133,7 @@
       </p:sp>
       <p:pic>
         <p:nvPicPr>
-          <p:cNvPr id="3" name="Picture 2" descr="012_210x206_1216.jpg"/>
+          <p:cNvPr id="3" name="Picture 2" descr="012_210x206_b3db79.jpg"/>
           <p:cNvPicPr>
             <a:picLocks noChangeAspect="1"/>
           </p:cNvPicPr>
@@ -3205,7 +3205,7 @@
       </p:pic>
       <p:pic>
         <p:nvPicPr>
-          <p:cNvPr id="6" name="Picture 5" descr="logo_white.png"/>
+          <p:cNvPr id="6" name="Picture 5" descr="logo_white_9a78fa.png"/>
           <p:cNvPicPr>
             <a:picLocks noChangeAspect="1"/>
           </p:cNvPicPr>
@@ -3255,7 +3255,7 @@
               </a:lnSpc>
             </a:pPr>
             <a:r>
-              <a:rPr sz="1300" b="1" spc="208">
+              <a:rPr sz="1300" b="1" i="0" spc="208">
                 <a:solidFill>
                   <a:srgbClr val="C9A26B"/>
                 </a:solidFill>
@@ -3323,7 +3323,7 @@
               </a:lnSpc>
             </a:pPr>
             <a:r>
-              <a:rPr sz="1300" b="1" spc="208">
+              <a:rPr sz="1300" b="1" i="0" spc="208">
                 <a:solidFill>
                   <a:srgbClr val="C9A26B"/>
                 </a:solidFill>
@@ -3362,7 +3362,7 @@
               </a:lnSpc>
             </a:pPr>
             <a:r>
-              <a:rPr sz="5600" b="1" spc="28">
+              <a:rPr sz="5600" b="1" i="0" spc="28">
                 <a:solidFill>
                   <a:srgbClr val="F4F2EE"/>
                 </a:solidFill>
@@ -3378,7 +3378,7 @@
               </a:lnSpc>
             </a:pPr>
             <a:r>
-              <a:rPr sz="5600" b="1" spc="28">
+              <a:rPr sz="5600" b="1" i="0" spc="28">
                 <a:solidFill>
                   <a:srgbClr val="F4F2EE"/>
                 </a:solidFill>
@@ -3387,7 +3387,7 @@
               <a:t>VALORIZA SEU </a:t>
             </a:r>
             <a:r>
-              <a:rPr sz="5600" b="1" spc="28">
+              <a:rPr sz="5600" b="1" i="0" spc="28">
                 <a:solidFill>
                   <a:srgbClr val="C9A26B"/>
                 </a:solidFill>
@@ -3426,7 +3426,7 @@
               </a:lnSpc>
             </a:pPr>
             <a:r>
-              <a:rPr sz="1700" b="0">
+              <a:rPr sz="1700" b="0" i="0">
                 <a:solidFill>
                   <a:srgbClr val="D9D6D0"/>
                 </a:solidFill>
@@ -3500,7 +3500,7 @@
               </a:lnSpc>
             </a:pPr>
             <a:r>
-              <a:rPr sz="1600" b="1" spc="96">
+              <a:rPr sz="1600" b="1" i="0" spc="96">
                 <a:solidFill>
                   <a:srgbClr val="0E0F11"/>
                 </a:solidFill>
@@ -3516,7 +3516,7 @@
               </a:lnSpc>
             </a:pPr>
             <a:r>
-              <a:rPr sz="1600" b="1" spc="96">
+              <a:rPr sz="1600" b="1" i="0" spc="96">
                 <a:solidFill>
                   <a:srgbClr val="3B2E1C"/>
                 </a:solidFill>
@@ -3557,7 +3557,7 @@
               </a:lnSpc>
             </a:pPr>
             <a:r>
-              <a:rPr sz="3000" b="1">
+              <a:rPr sz="3000" b="1" i="0">
                 <a:solidFill>
                   <a:srgbClr val="0E0F11"/>
                 </a:solidFill>
@@ -3625,7 +3625,7 @@
       </p:sp>
       <p:pic>
         <p:nvPicPr>
-          <p:cNvPr id="3" name="Picture 2" descr="007_210x122_33bd.jpg"/>
+          <p:cNvPr id="3" name="Picture 2" descr="007_210x122_4053b6.jpg"/>
           <p:cNvPicPr>
             <a:picLocks noChangeAspect="1"/>
           </p:cNvPicPr>
@@ -3728,7 +3728,7 @@
               </a:lnSpc>
             </a:pPr>
             <a:r>
-              <a:rPr sz="1300" b="1" spc="208">
+              <a:rPr sz="1300" b="1" i="0" spc="208">
                 <a:solidFill>
                   <a:srgbClr val="C9A26B"/>
                 </a:solidFill>
@@ -3767,7 +3767,7 @@
               </a:lnSpc>
             </a:pPr>
             <a:r>
-              <a:rPr sz="4200" b="1">
+              <a:rPr sz="4200" b="1" i="0">
                 <a:solidFill>
                   <a:srgbClr val="F4F2EE"/>
                 </a:solidFill>
@@ -3783,7 +3783,7 @@
               </a:lnSpc>
             </a:pPr>
             <a:r>
-              <a:rPr sz="4200" b="1">
+              <a:rPr sz="4200" b="1" i="0">
                 <a:solidFill>
                   <a:srgbClr val="F4F2EE"/>
                 </a:solidFill>
@@ -3792,7 +3792,7 @@
               <a:t>E ESQUADRIAS DE </a:t>
             </a:r>
             <a:r>
-              <a:rPr sz="4200" b="1">
+              <a:rPr sz="4200" b="1" i="0">
                 <a:solidFill>
                   <a:srgbClr val="C9A26B"/>
                 </a:solidFill>
@@ -3831,7 +3831,7 @@
               </a:lnSpc>
             </a:pPr>
             <a:r>
-              <a:rPr sz="1700" b="0">
+              <a:rPr sz="1700" b="0" i="0">
                 <a:solidFill>
                   <a:srgbClr val="D9D6D0"/>
                 </a:solidFill>
@@ -3850,7 +3850,7 @@
               </a:spcBef>
             </a:pPr>
             <a:r>
-              <a:rPr sz="1700" b="0">
+              <a:rPr sz="1700" b="0" i="0">
                 <a:solidFill>
                   <a:srgbClr val="D9D6D0"/>
                 </a:solidFill>
@@ -3918,7 +3918,7 @@
               </a:lnSpc>
             </a:pPr>
             <a:r>
-              <a:rPr sz="2300" b="1" spc="46">
+              <a:rPr sz="2300" b="1" i="0" spc="46">
                 <a:solidFill>
                   <a:srgbClr val="F4F2EE"/>
                 </a:solidFill>
@@ -3957,7 +3957,7 @@
               </a:lnSpc>
             </a:pPr>
             <a:r>
-              <a:rPr sz="1400" b="0">
+              <a:rPr sz="1400" b="0" i="0">
                 <a:solidFill>
                   <a:srgbClr val="AEB2B8"/>
                 </a:solidFill>
@@ -4025,7 +4025,7 @@
               </a:lnSpc>
             </a:pPr>
             <a:r>
-              <a:rPr sz="2300" b="1" spc="46">
+              <a:rPr sz="2300" b="1" i="0" spc="46">
                 <a:solidFill>
                   <a:srgbClr val="F4F2EE"/>
                 </a:solidFill>
@@ -4064,7 +4064,7 @@
               </a:lnSpc>
             </a:pPr>
             <a:r>
-              <a:rPr sz="1400" b="0">
+              <a:rPr sz="1400" b="0" i="0">
                 <a:solidFill>
                   <a:srgbClr val="AEB2B8"/>
                 </a:solidFill>
@@ -4132,7 +4132,7 @@
               </a:lnSpc>
             </a:pPr>
             <a:r>
-              <a:rPr sz="2300" b="1" spc="46">
+              <a:rPr sz="2300" b="1" i="0" spc="46">
                 <a:solidFill>
                   <a:srgbClr val="F4F2EE"/>
                 </a:solidFill>
@@ -4171,7 +4171,7 @@
               </a:lnSpc>
             </a:pPr>
             <a:r>
-              <a:rPr sz="1400" b="0">
+              <a:rPr sz="1400" b="0" i="0">
                 <a:solidFill>
                   <a:srgbClr val="AEB2B8"/>
                 </a:solidFill>
@@ -4213,7 +4213,7 @@
       </p:sp>
       <p:pic>
         <p:nvPicPr>
-          <p:cNvPr id="19" name="Picture 18" descr="logo_white.png"/>
+          <p:cNvPr id="19" name="Picture 18" descr="logo_white_31b7da.png"/>
           <p:cNvPicPr>
             <a:picLocks noChangeAspect="1"/>
           </p:cNvPicPr>
@@ -4265,7 +4265,7 @@
               </a:lnSpc>
             </a:pPr>
             <a:r>
-              <a:rPr sz="1300" b="1" spc="39">
+              <a:rPr sz="1300" b="1" i="0" spc="39">
                 <a:solidFill>
                   <a:srgbClr val="F4F2EE"/>
                 </a:solidFill>
@@ -4274,7 +4274,7 @@
               <a:t>Orçamentos com Felipe  </a:t>
             </a:r>
             <a:r>
-              <a:rPr sz="1300" b="1" spc="39">
+              <a:rPr sz="1300" b="1" i="0" spc="39">
                 <a:solidFill>
                   <a:srgbClr val="C9A26B"/>
                 </a:solidFill>
@@ -4397,7 +4397,7 @@
               </a:lnSpc>
             </a:pPr>
             <a:r>
-              <a:rPr sz="1300" b="1" spc="208">
+              <a:rPr sz="1300" b="1" i="0" spc="208">
                 <a:solidFill>
                   <a:srgbClr val="C9A26B"/>
                 </a:solidFill>
@@ -4436,7 +4436,7 @@
               </a:lnSpc>
             </a:pPr>
             <a:r>
-              <a:rPr sz="4200" b="1">
+              <a:rPr sz="4200" b="1" i="0">
                 <a:solidFill>
                   <a:srgbClr val="F4F2EE"/>
                 </a:solidFill>
@@ -4452,7 +4452,7 @@
               </a:lnSpc>
             </a:pPr>
             <a:r>
-              <a:rPr sz="4200" b="1">
+              <a:rPr sz="4200" b="1" i="0">
                 <a:solidFill>
                   <a:srgbClr val="F4F2EE"/>
                 </a:solidFill>
@@ -4461,7 +4461,7 @@
               <a:t>EM VIDRO E </a:t>
             </a:r>
             <a:r>
-              <a:rPr sz="4200" b="1">
+              <a:rPr sz="4200" b="1" i="0">
                 <a:solidFill>
                   <a:srgbClr val="C9A26B"/>
                 </a:solidFill>
@@ -4500,7 +4500,7 @@
               </a:lnSpc>
             </a:pPr>
             <a:r>
-              <a:rPr sz="1650" b="0">
+              <a:rPr sz="1650" b="0" i="0">
                 <a:solidFill>
                   <a:srgbClr val="AEB2B8"/>
                 </a:solidFill>
@@ -4542,7 +4542,7 @@
       </p:sp>
       <p:pic>
         <p:nvPicPr>
-          <p:cNvPr id="8" name="Picture 7" descr="013_86x43_8e09.jpg"/>
+          <p:cNvPr id="8" name="Picture 7" descr="013_86x43_28a0e3.jpg"/>
           <p:cNvPicPr>
             <a:picLocks noChangeAspect="1"/>
           </p:cNvPicPr>
@@ -4592,7 +4592,7 @@
               </a:lnSpc>
             </a:pPr>
             <a:r>
-              <a:rPr sz="1700" b="1" spc="51">
+              <a:rPr sz="1700" b="1" i="0" spc="51">
                 <a:solidFill>
                   <a:srgbClr val="F4F2EE"/>
                 </a:solidFill>
@@ -4631,7 +4631,7 @@
               </a:lnSpc>
             </a:pPr>
             <a:r>
-              <a:rPr sz="1350" b="0">
+              <a:rPr sz="1350" b="0" i="0">
                 <a:solidFill>
                   <a:srgbClr val="AEB2B8"/>
                 </a:solidFill>
@@ -4673,7 +4673,7 @@
       </p:sp>
       <p:pic>
         <p:nvPicPr>
-          <p:cNvPr id="12" name="Picture 11" descr="050_86x43_348b.jpg"/>
+          <p:cNvPr id="12" name="Picture 11" descr="050_86x43_2612fe.jpg"/>
           <p:cNvPicPr>
             <a:picLocks noChangeAspect="1"/>
           </p:cNvPicPr>
@@ -4723,7 +4723,7 @@
               </a:lnSpc>
             </a:pPr>
             <a:r>
-              <a:rPr sz="1700" b="1" spc="51">
+              <a:rPr sz="1700" b="1" i="0" spc="51">
                 <a:solidFill>
                   <a:srgbClr val="F4F2EE"/>
                 </a:solidFill>
@@ -4762,7 +4762,7 @@
               </a:lnSpc>
             </a:pPr>
             <a:r>
-              <a:rPr sz="1350" b="0">
+              <a:rPr sz="1350" b="0" i="0">
                 <a:solidFill>
                   <a:srgbClr val="AEB2B8"/>
                 </a:solidFill>
@@ -4804,7 +4804,7 @@
       </p:sp>
       <p:pic>
         <p:nvPicPr>
-          <p:cNvPr id="16" name="Picture 15" descr="040_86x43_33bd.jpg"/>
+          <p:cNvPr id="16" name="Picture 15" descr="040_86x43_59a56e.jpg"/>
           <p:cNvPicPr>
             <a:picLocks noChangeAspect="1"/>
           </p:cNvPicPr>
@@ -4854,7 +4854,7 @@
               </a:lnSpc>
             </a:pPr>
             <a:r>
-              <a:rPr sz="1700" b="1" spc="51">
+              <a:rPr sz="1700" b="1" i="0" spc="51">
                 <a:solidFill>
                   <a:srgbClr val="F4F2EE"/>
                 </a:solidFill>
@@ -4893,7 +4893,7 @@
               </a:lnSpc>
             </a:pPr>
             <a:r>
-              <a:rPr sz="1350" b="0">
+              <a:rPr sz="1350" b="0" i="0">
                 <a:solidFill>
                   <a:srgbClr val="AEB2B8"/>
                 </a:solidFill>
@@ -4935,7 +4935,7 @@
       </p:sp>
       <p:pic>
         <p:nvPicPr>
-          <p:cNvPr id="20" name="Picture 19" descr="041_86x43_348b.jpg"/>
+          <p:cNvPr id="20" name="Picture 19" descr="041_86x43_3f646c.jpg"/>
           <p:cNvPicPr>
             <a:picLocks noChangeAspect="1"/>
           </p:cNvPicPr>
@@ -4985,7 +4985,7 @@
               </a:lnSpc>
             </a:pPr>
             <a:r>
-              <a:rPr sz="1700" b="1" spc="51">
+              <a:rPr sz="1700" b="1" i="0" spc="51">
                 <a:solidFill>
                   <a:srgbClr val="F4F2EE"/>
                 </a:solidFill>
@@ -5024,7 +5024,7 @@
               </a:lnSpc>
             </a:pPr>
             <a:r>
-              <a:rPr sz="1350" b="0">
+              <a:rPr sz="1350" b="0" i="0">
                 <a:solidFill>
                   <a:srgbClr val="AEB2B8"/>
                 </a:solidFill>
@@ -5121,7 +5121,7 @@
               </a:lnSpc>
             </a:pPr>
             <a:r>
-              <a:rPr sz="1250" b="1" spc="200">
+              <a:rPr sz="1250" b="1" i="0" spc="200">
                 <a:solidFill>
                   <a:srgbClr val="C9A26B"/>
                 </a:solidFill>
@@ -5192,7 +5192,7 @@
       </p:sp>
       <p:pic>
         <p:nvPicPr>
-          <p:cNvPr id="28" name="Picture 27" descr="icon_espelho.png"/>
+          <p:cNvPr id="28" name="Picture 27" descr="icon_espelho_d78ab0.png"/>
           <p:cNvPicPr>
             <a:picLocks noChangeAspect="1"/>
           </p:cNvPicPr>
@@ -5242,7 +5242,7 @@
               </a:lnSpc>
             </a:pPr>
             <a:r>
-              <a:rPr sz="1550" b="1" spc="46">
+              <a:rPr sz="1550" b="1" i="0" spc="46">
                 <a:solidFill>
                   <a:srgbClr val="F4F2EE"/>
                 </a:solidFill>
@@ -5281,7 +5281,7 @@
               </a:lnSpc>
             </a:pPr>
             <a:r>
-              <a:rPr sz="1350" b="0">
+              <a:rPr sz="1350" b="0" i="0">
                 <a:solidFill>
                   <a:srgbClr val="AEB2B8"/>
                 </a:solidFill>
@@ -5323,7 +5323,7 @@
       </p:sp>
       <p:pic>
         <p:nvPicPr>
-          <p:cNvPr id="32" name="Picture 31" descr="icon_pergolado.png"/>
+          <p:cNvPr id="32" name="Picture 31" descr="icon_pergolado_003312.png"/>
           <p:cNvPicPr>
             <a:picLocks noChangeAspect="1"/>
           </p:cNvPicPr>
@@ -5373,7 +5373,7 @@
               </a:lnSpc>
             </a:pPr>
             <a:r>
-              <a:rPr sz="1550" b="1" spc="46">
+              <a:rPr sz="1550" b="1" i="0" spc="46">
                 <a:solidFill>
                   <a:srgbClr val="F4F2EE"/>
                 </a:solidFill>
@@ -5412,7 +5412,7 @@
               </a:lnSpc>
             </a:pPr>
             <a:r>
-              <a:rPr sz="1350" b="0">
+              <a:rPr sz="1350" b="0" i="0">
                 <a:solidFill>
                   <a:srgbClr val="AEB2B8"/>
                 </a:solidFill>
@@ -5454,7 +5454,7 @@
       </p:sp>
       <p:pic>
         <p:nvPicPr>
-          <p:cNvPr id="36" name="Picture 35" descr="logo_white.png"/>
+          <p:cNvPr id="36" name="Picture 35" descr="logo_white_31b7da.png"/>
           <p:cNvPicPr>
             <a:picLocks noChangeAspect="1"/>
           </p:cNvPicPr>
@@ -5506,7 +5506,7 @@
               </a:lnSpc>
             </a:pPr>
             <a:r>
-              <a:rPr sz="1300" b="1" spc="39">
+              <a:rPr sz="1300" b="1" i="0" spc="39">
                 <a:solidFill>
                   <a:srgbClr val="F4F2EE"/>
                 </a:solidFill>
@@ -5515,7 +5515,7 @@
               <a:t>Orçamentos com Felipe  </a:t>
             </a:r>
             <a:r>
-              <a:rPr sz="1300" b="1" spc="39">
+              <a:rPr sz="1300" b="1" i="0" spc="39">
                 <a:solidFill>
                   <a:srgbClr val="C9A26B"/>
                 </a:solidFill>
@@ -5638,7 +5638,7 @@
               </a:lnSpc>
             </a:pPr>
             <a:r>
-              <a:rPr sz="1300" b="1" spc="208">
+              <a:rPr sz="1300" b="1" i="0" spc="208">
                 <a:solidFill>
                   <a:srgbClr val="C9A26B"/>
                 </a:solidFill>
@@ -5677,7 +5677,7 @@
               </a:lnSpc>
             </a:pPr>
             <a:r>
-              <a:rPr sz="4200" b="1">
+              <a:rPr sz="4200" b="1" i="0">
                 <a:solidFill>
                   <a:srgbClr val="F4F2EE"/>
                 </a:solidFill>
@@ -5693,7 +5693,7 @@
               </a:lnSpc>
             </a:pPr>
             <a:r>
-              <a:rPr sz="4200" b="1">
+              <a:rPr sz="4200" b="1" i="0">
                 <a:solidFill>
                   <a:srgbClr val="F4F2EE"/>
                 </a:solidFill>
@@ -5702,7 +5702,7 @@
               <a:t>FAZ A </a:t>
             </a:r>
             <a:r>
-              <a:rPr sz="4200" b="1">
+              <a:rPr sz="4200" b="1" i="0">
                 <a:solidFill>
                   <a:srgbClr val="C9A26B"/>
                 </a:solidFill>
@@ -5741,7 +5741,7 @@
               </a:lnSpc>
             </a:pPr>
             <a:r>
-              <a:rPr sz="1650" b="0">
+              <a:rPr sz="1650" b="0" i="0">
                 <a:solidFill>
                   <a:srgbClr val="AEB2B8"/>
                 </a:solidFill>
@@ -5754,7 +5754,7 @@
       </p:sp>
       <p:pic>
         <p:nvPicPr>
-          <p:cNvPr id="7" name="Picture 6" descr="049_104x186_348b.jpg"/>
+          <p:cNvPr id="7" name="Picture 6" descr="049_104x186_cd2abb.jpg"/>
           <p:cNvPicPr>
             <a:picLocks noChangeAspect="1"/>
           </p:cNvPicPr>
@@ -5828,7 +5828,7 @@
               </a:lnSpc>
             </a:pPr>
             <a:r>
-              <a:rPr sz="1700" b="1" spc="68">
+              <a:rPr sz="1700" b="1" i="0" spc="68">
                 <a:solidFill>
                   <a:srgbClr val="F4F2EE"/>
                 </a:solidFill>
@@ -5867,7 +5867,7 @@
               </a:lnSpc>
             </a:pPr>
             <a:r>
-              <a:rPr sz="1350" b="0">
+              <a:rPr sz="1350" b="0" i="0">
                 <a:solidFill>
                   <a:srgbClr val="D9D6D0"/>
                 </a:solidFill>
@@ -5880,7 +5880,7 @@
       </p:sp>
       <p:pic>
         <p:nvPicPr>
-          <p:cNvPr id="11" name="Picture 10" descr="037_68x59_3afa.jpg"/>
+          <p:cNvPr id="11" name="Picture 10" descr="037_68x59_6b7d47.jpg"/>
           <p:cNvPicPr>
             <a:picLocks noChangeAspect="1"/>
           </p:cNvPicPr>
@@ -5954,7 +5954,7 @@
               </a:lnSpc>
             </a:pPr>
             <a:r>
-              <a:rPr sz="1550" b="1" spc="78">
+              <a:rPr sz="1550" b="1" i="0" spc="78">
                 <a:solidFill>
                   <a:srgbClr val="F4F2EE"/>
                 </a:solidFill>
@@ -5967,7 +5967,7 @@
       </p:sp>
       <p:pic>
         <p:nvPicPr>
-          <p:cNvPr id="14" name="Picture 13" descr="044_68x59_bfaf.jpg"/>
+          <p:cNvPr id="14" name="Picture 13" descr="044_68x59_9a0e82.jpg"/>
           <p:cNvPicPr>
             <a:picLocks noChangeAspect="1"/>
           </p:cNvPicPr>
@@ -6041,7 +6041,7 @@
               </a:lnSpc>
             </a:pPr>
             <a:r>
-              <a:rPr sz="1550" b="1" spc="78">
+              <a:rPr sz="1550" b="1" i="0" spc="78">
                 <a:solidFill>
                   <a:srgbClr val="F4F2EE"/>
                 </a:solidFill>
@@ -6054,7 +6054,7 @@
       </p:sp>
       <p:pic>
         <p:nvPicPr>
-          <p:cNvPr id="17" name="Picture 16" descr="047_68x59_9440.jpg"/>
+          <p:cNvPr id="17" name="Picture 16" descr="047_68x59_e07612.jpg"/>
           <p:cNvPicPr>
             <a:picLocks noChangeAspect="1"/>
           </p:cNvPicPr>
@@ -6128,7 +6128,7 @@
               </a:lnSpc>
             </a:pPr>
             <a:r>
-              <a:rPr sz="1550" b="1" spc="78">
+              <a:rPr sz="1550" b="1" i="0" spc="78">
                 <a:solidFill>
                   <a:srgbClr val="F4F2EE"/>
                 </a:solidFill>
@@ -6170,7 +6170,7 @@
       </p:sp>
       <p:pic>
         <p:nvPicPr>
-          <p:cNvPr id="21" name="Picture 20" descr="logo_white.png"/>
+          <p:cNvPr id="21" name="Picture 20" descr="logo_white_31b7da.png"/>
           <p:cNvPicPr>
             <a:picLocks noChangeAspect="1"/>
           </p:cNvPicPr>
@@ -6222,7 +6222,7 @@
               </a:lnSpc>
             </a:pPr>
             <a:r>
-              <a:rPr sz="1300" b="1" spc="39">
+              <a:rPr sz="1300" b="1" i="0" spc="39">
                 <a:solidFill>
                   <a:srgbClr val="F4F2EE"/>
                 </a:solidFill>
@@ -6231,7 +6231,7 @@
               <a:t>Orçamentos com Felipe  </a:t>
             </a:r>
             <a:r>
-              <a:rPr sz="1300" b="1" spc="39">
+              <a:rPr sz="1300" b="1" i="0" spc="39">
                 <a:solidFill>
                   <a:srgbClr val="C9A26B"/>
                 </a:solidFill>
@@ -6354,7 +6354,7 @@
               </a:lnSpc>
             </a:pPr>
             <a:r>
-              <a:rPr sz="1300" b="1" spc="208">
+              <a:rPr sz="1300" b="1" i="0" spc="208">
                 <a:solidFill>
                   <a:srgbClr val="8A6A3D"/>
                 </a:solidFill>
@@ -6393,7 +6393,7 @@
               </a:lnSpc>
             </a:pPr>
             <a:r>
-              <a:rPr sz="4200" b="1">
+              <a:rPr sz="4200" b="1" i="0">
                 <a:solidFill>
                   <a:srgbClr val="0E0F11"/>
                 </a:solidFill>
@@ -6409,7 +6409,7 @@
               </a:lnSpc>
             </a:pPr>
             <a:r>
-              <a:rPr sz="4200" b="1">
+              <a:rPr sz="4200" b="1" i="0">
                 <a:solidFill>
                   <a:srgbClr val="0E0F11"/>
                 </a:solidFill>
@@ -6418,7 +6418,7 @@
               <a:t>A JP </a:t>
             </a:r>
             <a:r>
-              <a:rPr sz="4200" b="1">
+              <a:rPr sz="4200" b="1" i="0">
                 <a:solidFill>
                   <a:srgbClr val="8A6A3D"/>
                 </a:solidFill>
@@ -6457,7 +6457,7 @@
               </a:lnSpc>
             </a:pPr>
             <a:r>
-              <a:rPr sz="1650" b="0">
+              <a:rPr sz="1650" b="0" i="0">
                 <a:solidFill>
                   <a:srgbClr val="4E5258"/>
                 </a:solidFill>
@@ -6525,7 +6525,7 @@
               </a:lnSpc>
             </a:pPr>
             <a:r>
-              <a:rPr sz="2600" b="1">
+              <a:rPr sz="2600" b="1" i="0">
                 <a:solidFill>
                   <a:srgbClr val="8A6A3D"/>
                 </a:solidFill>
@@ -6564,7 +6564,7 @@
               </a:lnSpc>
             </a:pPr>
             <a:r>
-              <a:rPr sz="1750" b="1" spc="52">
+              <a:rPr sz="1750" b="1" i="0" spc="52">
                 <a:solidFill>
                   <a:srgbClr val="0E0F11"/>
                 </a:solidFill>
@@ -6603,7 +6603,7 @@
               </a:lnSpc>
             </a:pPr>
             <a:r>
-              <a:rPr sz="1450" b="0">
+              <a:rPr sz="1450" b="0" i="0">
                 <a:solidFill>
                   <a:srgbClr val="4E5258"/>
                 </a:solidFill>
@@ -6671,7 +6671,7 @@
               </a:lnSpc>
             </a:pPr>
             <a:r>
-              <a:rPr sz="2600" b="1">
+              <a:rPr sz="2600" b="1" i="0">
                 <a:solidFill>
                   <a:srgbClr val="8A6A3D"/>
                 </a:solidFill>
@@ -6710,7 +6710,7 @@
               </a:lnSpc>
             </a:pPr>
             <a:r>
-              <a:rPr sz="1750" b="1" spc="52">
+              <a:rPr sz="1750" b="1" i="0" spc="52">
                 <a:solidFill>
                   <a:srgbClr val="0E0F11"/>
                 </a:solidFill>
@@ -6749,7 +6749,7 @@
               </a:lnSpc>
             </a:pPr>
             <a:r>
-              <a:rPr sz="1450" b="0">
+              <a:rPr sz="1450" b="0" i="0">
                 <a:solidFill>
                   <a:srgbClr val="4E5258"/>
                 </a:solidFill>
@@ -6817,7 +6817,7 @@
               </a:lnSpc>
             </a:pPr>
             <a:r>
-              <a:rPr sz="2600" b="1">
+              <a:rPr sz="2600" b="1" i="0">
                 <a:solidFill>
                   <a:srgbClr val="8A6A3D"/>
                 </a:solidFill>
@@ -6856,7 +6856,7 @@
               </a:lnSpc>
             </a:pPr>
             <a:r>
-              <a:rPr sz="1750" b="1" spc="52">
+              <a:rPr sz="1750" b="1" i="0" spc="52">
                 <a:solidFill>
                   <a:srgbClr val="0E0F11"/>
                 </a:solidFill>
@@ -6895,7 +6895,7 @@
               </a:lnSpc>
             </a:pPr>
             <a:r>
-              <a:rPr sz="1450" b="0">
+              <a:rPr sz="1450" b="0" i="0">
                 <a:solidFill>
                   <a:srgbClr val="4E5258"/>
                 </a:solidFill>
@@ -6963,7 +6963,7 @@
               </a:lnSpc>
             </a:pPr>
             <a:r>
-              <a:rPr sz="2600" b="1">
+              <a:rPr sz="2600" b="1" i="0">
                 <a:solidFill>
                   <a:srgbClr val="8A6A3D"/>
                 </a:solidFill>
@@ -7002,7 +7002,7 @@
               </a:lnSpc>
             </a:pPr>
             <a:r>
-              <a:rPr sz="1750" b="1" spc="52">
+              <a:rPr sz="1750" b="1" i="0" spc="52">
                 <a:solidFill>
                   <a:srgbClr val="0E0F11"/>
                 </a:solidFill>
@@ -7041,7 +7041,7 @@
               </a:lnSpc>
             </a:pPr>
             <a:r>
-              <a:rPr sz="1450" b="0">
+              <a:rPr sz="1450" b="0" i="0">
                 <a:solidFill>
                   <a:srgbClr val="4E5258"/>
                 </a:solidFill>
@@ -7109,7 +7109,7 @@
               </a:lnSpc>
             </a:pPr>
             <a:r>
-              <a:rPr sz="2600" b="1">
+              <a:rPr sz="2600" b="1" i="0">
                 <a:solidFill>
                   <a:srgbClr val="8A6A3D"/>
                 </a:solidFill>
@@ -7148,7 +7148,7 @@
               </a:lnSpc>
             </a:pPr>
             <a:r>
-              <a:rPr sz="1750" b="1" spc="52">
+              <a:rPr sz="1750" b="1" i="0" spc="52">
                 <a:solidFill>
                   <a:srgbClr val="0E0F11"/>
                 </a:solidFill>
@@ -7187,7 +7187,7 @@
               </a:lnSpc>
             </a:pPr>
             <a:r>
-              <a:rPr sz="1450" b="0">
+              <a:rPr sz="1450" b="0" i="0">
                 <a:solidFill>
                   <a:srgbClr val="4E5258"/>
                 </a:solidFill>
@@ -7255,7 +7255,7 @@
               </a:lnSpc>
             </a:pPr>
             <a:r>
-              <a:rPr sz="2600" b="1">
+              <a:rPr sz="2600" b="1" i="0">
                 <a:solidFill>
                   <a:srgbClr val="8A6A3D"/>
                 </a:solidFill>
@@ -7294,7 +7294,7 @@
               </a:lnSpc>
             </a:pPr>
             <a:r>
-              <a:rPr sz="1750" b="1" spc="52">
+              <a:rPr sz="1750" b="1" i="0" spc="52">
                 <a:solidFill>
                   <a:srgbClr val="0E0F11"/>
                 </a:solidFill>
@@ -7333,7 +7333,7 @@
               </a:lnSpc>
             </a:pPr>
             <a:r>
-              <a:rPr sz="1450" b="0">
+              <a:rPr sz="1450" b="0" i="0">
                 <a:solidFill>
                   <a:srgbClr val="4E5258"/>
                 </a:solidFill>
@@ -7346,7 +7346,7 @@
       </p:sp>
       <p:pic>
         <p:nvPicPr>
-          <p:cNvPr id="31" name="Picture 30" descr="046_210x71_4748.jpg"/>
+          <p:cNvPr id="31" name="Picture 30" descr="046_210x71_6906cf.jpg"/>
           <p:cNvPicPr>
             <a:picLocks noChangeAspect="1"/>
           </p:cNvPicPr>
@@ -7420,7 +7420,7 @@
               </a:lnSpc>
             </a:pPr>
             <a:r>
-              <a:rPr sz="2400" b="1" spc="24">
+              <a:rPr sz="2400" b="1" i="0" spc="24">
                 <a:solidFill>
                   <a:srgbClr val="F4F2EE"/>
                 </a:solidFill>
@@ -7436,7 +7436,7 @@
               </a:lnSpc>
             </a:pPr>
             <a:r>
-              <a:rPr sz="2400" b="1" spc="24">
+              <a:rPr sz="2400" b="1" i="0" spc="24">
                 <a:solidFill>
                   <a:srgbClr val="C9A26B"/>
                 </a:solidFill>
@@ -7478,7 +7478,7 @@
       </p:sp>
       <p:pic>
         <p:nvPicPr>
-          <p:cNvPr id="35" name="Picture 34" descr="logo_white.png"/>
+          <p:cNvPr id="35" name="Picture 34" descr="logo_white_31b7da.png"/>
           <p:cNvPicPr>
             <a:picLocks noChangeAspect="1"/>
           </p:cNvPicPr>
@@ -7530,7 +7530,7 @@
               </a:lnSpc>
             </a:pPr>
             <a:r>
-              <a:rPr sz="1300" b="1" spc="39">
+              <a:rPr sz="1300" b="1" i="0" spc="39">
                 <a:solidFill>
                   <a:srgbClr val="F4F2EE"/>
                 </a:solidFill>
@@ -7539,7 +7539,7 @@
               <a:t>Orçamentos com Felipe  </a:t>
             </a:r>
             <a:r>
-              <a:rPr sz="1300" b="1" spc="39">
+              <a:rPr sz="1300" b="1" i="0" spc="39">
                 <a:solidFill>
                   <a:srgbClr val="C9A26B"/>
                 </a:solidFill>
@@ -7662,7 +7662,7 @@
               </a:lnSpc>
             </a:pPr>
             <a:r>
-              <a:rPr sz="1300" b="1" spc="208">
+              <a:rPr sz="1300" b="1" i="0" spc="208">
                 <a:solidFill>
                   <a:srgbClr val="C9A26B"/>
                 </a:solidFill>
@@ -7701,7 +7701,7 @@
               </a:lnSpc>
             </a:pPr>
             <a:r>
-              <a:rPr sz="4200" b="1">
+              <a:rPr sz="4200" b="1" i="0">
                 <a:solidFill>
                   <a:srgbClr val="F4F2EE"/>
                 </a:solidFill>
@@ -7717,7 +7717,7 @@
               </a:lnSpc>
             </a:pPr>
             <a:r>
-              <a:rPr sz="4200" b="1">
+              <a:rPr sz="4200" b="1" i="0">
                 <a:solidFill>
                   <a:srgbClr val="F4F2EE"/>
                 </a:solidFill>
@@ -7726,7 +7726,7 @@
               <a:t>SEU </a:t>
             </a:r>
             <a:r>
-              <a:rPr sz="4200" b="1">
+              <a:rPr sz="4200" b="1" i="0">
                 <a:solidFill>
                   <a:srgbClr val="C9A26B"/>
                 </a:solidFill>
@@ -7765,7 +7765,7 @@
               </a:lnSpc>
             </a:pPr>
             <a:r>
-              <a:rPr sz="1650" b="0">
+              <a:rPr sz="1650" b="0" i="0">
                 <a:solidFill>
                   <a:srgbClr val="AEB2B8"/>
                 </a:solidFill>
@@ -7778,7 +7778,7 @@
       </p:sp>
       <p:pic>
         <p:nvPicPr>
-          <p:cNvPr id="7" name="Picture 6" descr="045_86x85_3afa.jpg"/>
+          <p:cNvPr id="7" name="Picture 6" descr="045_86x85_50ff67.jpg"/>
           <p:cNvPicPr>
             <a:picLocks noChangeAspect="1"/>
           </p:cNvPicPr>
@@ -7852,7 +7852,7 @@
               </a:lnSpc>
             </a:pPr>
             <a:r>
-              <a:rPr sz="1550" b="1" spc="78">
+              <a:rPr sz="1550" b="1" i="0" spc="78">
                 <a:solidFill>
                   <a:srgbClr val="F4F2EE"/>
                 </a:solidFill>
@@ -7865,7 +7865,7 @@
       </p:sp>
       <p:pic>
         <p:nvPicPr>
-          <p:cNvPr id="10" name="Picture 9" descr="048_86x85_dca0.jpg"/>
+          <p:cNvPr id="10" name="Picture 9" descr="048_86x85_0e00b3.jpg"/>
           <p:cNvPicPr>
             <a:picLocks noChangeAspect="1"/>
           </p:cNvPicPr>
@@ -7939,7 +7939,7 @@
               </a:lnSpc>
             </a:pPr>
             <a:r>
-              <a:rPr sz="1550" b="1" spc="78">
+              <a:rPr sz="1550" b="1" i="0" spc="78">
                 <a:solidFill>
                   <a:srgbClr val="F4F2EE"/>
                 </a:solidFill>
@@ -7952,7 +7952,7 @@
       </p:sp>
       <p:pic>
         <p:nvPicPr>
-          <p:cNvPr id="13" name="Picture 12" descr="015_86x85_3afa.jpg"/>
+          <p:cNvPr id="13" name="Picture 12" descr="015_86x85_2ef2ec.jpg"/>
           <p:cNvPicPr>
             <a:picLocks noChangeAspect="1"/>
           </p:cNvPicPr>
@@ -8026,7 +8026,7 @@
               </a:lnSpc>
             </a:pPr>
             <a:r>
-              <a:rPr sz="1550" b="1" spc="78">
+              <a:rPr sz="1550" b="1" i="0" spc="78">
                 <a:solidFill>
                   <a:srgbClr val="F4F2EE"/>
                 </a:solidFill>
@@ -8039,7 +8039,7 @@
       </p:sp>
       <p:pic>
         <p:nvPicPr>
-          <p:cNvPr id="16" name="Picture 15" descr="023_86x85_3afa.jpg"/>
+          <p:cNvPr id="16" name="Picture 15" descr="023_86x85_2e951c.jpg"/>
           <p:cNvPicPr>
             <a:picLocks noChangeAspect="1"/>
           </p:cNvPicPr>
@@ -8113,7 +8113,7 @@
               </a:lnSpc>
             </a:pPr>
             <a:r>
-              <a:rPr sz="1550" b="1" spc="78">
+              <a:rPr sz="1550" b="1" i="0" spc="78">
                 <a:solidFill>
                   <a:srgbClr val="F4F2EE"/>
                 </a:solidFill>
@@ -8152,7 +8152,7 @@
               </a:lnSpc>
             </a:pPr>
             <a:r>
-              <a:rPr sz="1300" b="1" spc="156">
+              <a:rPr sz="1300" b="1" i="0" spc="156">
                 <a:solidFill>
                   <a:srgbClr val="C9A26B"/>
                 </a:solidFill>
@@ -8194,7 +8194,7 @@
       </p:sp>
       <p:pic>
         <p:nvPicPr>
-          <p:cNvPr id="21" name="Picture 20" descr="logo_white.png"/>
+          <p:cNvPr id="21" name="Picture 20" descr="logo_white_31b7da.png"/>
           <p:cNvPicPr>
             <a:picLocks noChangeAspect="1"/>
           </p:cNvPicPr>
@@ -8246,7 +8246,7 @@
               </a:lnSpc>
             </a:pPr>
             <a:r>
-              <a:rPr sz="1300" b="1" spc="39">
+              <a:rPr sz="1300" b="1" i="0" spc="39">
                 <a:solidFill>
                   <a:srgbClr val="F4F2EE"/>
                 </a:solidFill>
@@ -8255,7 +8255,7 @@
               <a:t>Orçamentos com Felipe  </a:t>
             </a:r>
             <a:r>
-              <a:rPr sz="1300" b="1" spc="39">
+              <a:rPr sz="1300" b="1" i="0" spc="39">
                 <a:solidFill>
                   <a:srgbClr val="C9A26B"/>
                 </a:solidFill>
@@ -8323,7 +8323,7 @@
       </p:sp>
       <p:pic>
         <p:nvPicPr>
-          <p:cNvPr id="3" name="Picture 2" descr="038_210x104_9d36.jpg"/>
+          <p:cNvPr id="3" name="Picture 2" descr="038_210x104_243636.jpg"/>
           <p:cNvPicPr>
             <a:picLocks noChangeAspect="1"/>
           </p:cNvPicPr>
@@ -8426,7 +8426,7 @@
               </a:lnSpc>
             </a:pPr>
             <a:r>
-              <a:rPr sz="1300" b="1" spc="208">
+              <a:rPr sz="1300" b="1" i="0" spc="208">
                 <a:solidFill>
                   <a:srgbClr val="C9A26B"/>
                 </a:solidFill>
@@ -8465,7 +8465,7 @@
               </a:lnSpc>
             </a:pPr>
             <a:r>
-              <a:rPr sz="4600" b="1">
+              <a:rPr sz="4600" b="1" i="0">
                 <a:solidFill>
                   <a:srgbClr val="F4F2EE"/>
                 </a:solidFill>
@@ -8481,7 +8481,7 @@
               </a:lnSpc>
             </a:pPr>
             <a:r>
-              <a:rPr sz="4600" b="1">
+              <a:rPr sz="4600" b="1" i="0">
                 <a:solidFill>
                   <a:srgbClr val="F4F2EE"/>
                 </a:solidFill>
@@ -8490,7 +8490,7 @@
               <a:t>PROJETO DO </a:t>
             </a:r>
             <a:r>
-              <a:rPr sz="4600" b="1">
+              <a:rPr sz="4600" b="1" i="0">
                 <a:solidFill>
                   <a:srgbClr val="C9A26B"/>
                 </a:solidFill>
@@ -8529,7 +8529,7 @@
               </a:lnSpc>
             </a:pPr>
             <a:r>
-              <a:rPr sz="1650" b="0">
+              <a:rPr sz="1650" b="0" i="0">
                 <a:solidFill>
                   <a:srgbClr val="D9D6D0"/>
                 </a:solidFill>
@@ -8597,7 +8597,7 @@
               </a:lnSpc>
             </a:pPr>
             <a:r>
-              <a:rPr sz="1600" b="1">
+              <a:rPr sz="1600" b="1" i="0">
                 <a:solidFill>
                   <a:srgbClr val="C9A26B"/>
                 </a:solidFill>
@@ -8636,7 +8636,7 @@
               </a:lnSpc>
             </a:pPr>
             <a:r>
-              <a:rPr sz="1550" b="1" spc="46">
+              <a:rPr sz="1550" b="1" i="0" spc="46">
                 <a:solidFill>
                   <a:srgbClr val="F4F2EE"/>
                 </a:solidFill>
@@ -8675,7 +8675,7 @@
               </a:lnSpc>
             </a:pPr>
             <a:r>
-              <a:rPr sz="1350" b="0">
+              <a:rPr sz="1350" b="0" i="0">
                 <a:solidFill>
                   <a:srgbClr val="AEB2B8"/>
                 </a:solidFill>
@@ -8743,7 +8743,7 @@
               </a:lnSpc>
             </a:pPr>
             <a:r>
-              <a:rPr sz="1600" b="1">
+              <a:rPr sz="1600" b="1" i="0">
                 <a:solidFill>
                   <a:srgbClr val="C9A26B"/>
                 </a:solidFill>
@@ -8782,7 +8782,7 @@
               </a:lnSpc>
             </a:pPr>
             <a:r>
-              <a:rPr sz="1550" b="1" spc="46">
+              <a:rPr sz="1550" b="1" i="0" spc="46">
                 <a:solidFill>
                   <a:srgbClr val="F4F2EE"/>
                 </a:solidFill>
@@ -8821,7 +8821,7 @@
               </a:lnSpc>
             </a:pPr>
             <a:r>
-              <a:rPr sz="1350" b="0">
+              <a:rPr sz="1350" b="0" i="0">
                 <a:solidFill>
                   <a:srgbClr val="AEB2B8"/>
                 </a:solidFill>
@@ -8889,7 +8889,7 @@
               </a:lnSpc>
             </a:pPr>
             <a:r>
-              <a:rPr sz="1600" b="1">
+              <a:rPr sz="1600" b="1" i="0">
                 <a:solidFill>
                   <a:srgbClr val="C9A26B"/>
                 </a:solidFill>
@@ -8928,7 +8928,7 @@
               </a:lnSpc>
             </a:pPr>
             <a:r>
-              <a:rPr sz="1550" b="1" spc="46">
+              <a:rPr sz="1550" b="1" i="0" spc="46">
                 <a:solidFill>
                   <a:srgbClr val="F4F2EE"/>
                 </a:solidFill>
@@ -8967,7 +8967,7 @@
               </a:lnSpc>
             </a:pPr>
             <a:r>
-              <a:rPr sz="1350" b="0">
+              <a:rPr sz="1350" b="0" i="0">
                 <a:solidFill>
                   <a:srgbClr val="AEB2B8"/>
                 </a:solidFill>
@@ -9066,7 +9066,7 @@
               </a:lnSpc>
             </a:pPr>
             <a:r>
-              <a:rPr sz="1350" b="1" spc="189">
+              <a:rPr sz="1350" b="1" i="0" spc="189">
                 <a:solidFill>
                   <a:srgbClr val="C9A26B"/>
                 </a:solidFill>
@@ -9107,7 +9107,7 @@
               </a:lnSpc>
             </a:pPr>
             <a:r>
-              <a:rPr sz="4600" b="1">
+              <a:rPr sz="4600" b="1" i="0">
                 <a:solidFill>
                   <a:srgbClr val="F4F2EE"/>
                 </a:solidFill>
@@ -9181,7 +9181,7 @@
               </a:lnSpc>
             </a:pPr>
             <a:r>
-              <a:rPr sz="1500" b="1" spc="120">
+              <a:rPr sz="1500" b="1" i="0" spc="120">
                 <a:solidFill>
                   <a:srgbClr val="0E0F11"/>
                 </a:solidFill>
@@ -9279,7 +9279,7 @@
               </a:lnSpc>
             </a:pPr>
             <a:r>
-              <a:rPr sz="1150" b="1" spc="161">
+              <a:rPr sz="1150" b="1" i="0" spc="161">
                 <a:solidFill>
                   <a:srgbClr val="AEB2B8"/>
                 </a:solidFill>
@@ -9292,7 +9292,7 @@
       </p:sp>
       <p:pic>
         <p:nvPicPr>
-          <p:cNvPr id="30" name="Picture 29" descr="logo_white.png"/>
+          <p:cNvPr id="30" name="Picture 29" descr="logo_white_da8558.png"/>
           <p:cNvPicPr>
             <a:picLocks noChangeAspect="1"/>
           </p:cNvPicPr>
@@ -9342,7 +9342,7 @@
               </a:lnSpc>
             </a:pPr>
             <a:r>
-              <a:rPr sz="1200" b="1" spc="192">
+              <a:rPr sz="1200" b="1" i="0" spc="192">
                 <a:solidFill>
                   <a:srgbClr val="AEB2B8"/>
                 </a:solidFill>

</xml_diff>